<commit_message>
draft for team's review
</commit_message>
<xml_diff>
--- a/docs/milestone-1/Milestone1_Presentation.pptx
+++ b/docs/milestone-1/Milestone1_Presentation.pptx
@@ -511,7 +511,7 @@
           <a:lstStyle/>
           <a:p>
             <a:r>
-              <a:t>Learning is cross-referenced and propagated across courses. Mapping to be confirmed from IITM course content.</a:t>
+              <a:t>Learning is cross-referenced and propagated across levels. Levels map to NCERT classes (to be confirmed from the textbooks).</a:t>
             </a:r>
           </a:p>
         </p:txBody>
@@ -3834,7 +3834,7 @@
                 </a:solidFill>
                 <a:latin typeface="Calibri"/>
               </a:rPr>
-              <a:t>A study companion for IITM BS learners that guides them to the answer through probing questions, backtracking to earlier courses when needed. One pipeline, any course.</a:t>
+              <a:t>An intelligent small-scale tutor that guides a learner to the answer through probing questions, backtracking across levels when needed. One pipeline, any course.</a:t>
             </a:r>
           </a:p>
         </p:txBody>
@@ -4185,7 +4185,7 @@
                 </a:solidFill>
                 <a:latin typeface="Calibri"/>
               </a:rPr>
-              <a:t>•  A study companion for IITM BS learners that guides them to the answer with probing questions</a:t>
+              <a:t>•  A tutor that guides learners to the answer with probing questions</a:t>
             </a:r>
           </a:p>
           <a:p>
@@ -4217,7 +4217,7 @@
                 </a:solidFill>
                 <a:latin typeface="Calibri"/>
               </a:rPr>
-              <a:t>•  Backtracks across courses (Maths → MLF → MLT) to fix gaps, then climbs back up</a:t>
+              <a:t>•  Backtracks across levels to fix gaps, then climbs back up</a:t>
             </a:r>
           </a:p>
           <a:p>
@@ -4233,7 +4233,7 @@
                 </a:solidFill>
                 <a:latin typeface="Calibri"/>
               </a:rPr>
-              <a:t>•  Links mistakes to the exact lecture, slide or assignment</a:t>
+              <a:t>•  Links mistakes to the exact page, video or notes</a:t>
             </a:r>
           </a:p>
           <a:p>
@@ -4249,7 +4249,7 @@
                 </a:solidFill>
                 <a:latin typeface="Calibri"/>
               </a:rPr>
-              <a:t>•  Domain-agnostic: IITM BS (primary) and NCERT Maths via course packs</a:t>
+              <a:t>•  Works for any subject with study material: NCERT (primary) and IITM BS (secondary) via course packs</a:t>
             </a:r>
           </a:p>
           <a:p>
@@ -4526,6 +4526,117 @@
           </a:graphicData>
         </a:graphic>
       </p:graphicFrame>
+      <p:pic>
+        <p:nvPicPr>
+          <p:cNvPr id="9" name="Picture 8" descr="sandeep_nalla.jpg"/>
+          <p:cNvPicPr>
+            <a:picLocks noChangeAspect="1"/>
+          </p:cNvPicPr>
+          <p:nvPr/>
+        </p:nvPicPr>
+        <p:blipFill>
+          <a:blip r:embed="rId2"/>
+          <a:stretch>
+            <a:fillRect/>
+          </a:stretch>
+        </p:blipFill>
+        <p:spPr>
+          <a:xfrm>
+            <a:off x="9784080" y="1810512"/>
+            <a:ext cx="851611" cy="402336"/>
+          </a:xfrm>
+          <a:prstGeom prst="rect">
+            <a:avLst/>
+          </a:prstGeom>
+        </p:spPr>
+      </p:pic>
+      <p:pic>
+        <p:nvPicPr>
+          <p:cNvPr id="10" name="Picture 9" descr="hariom_kumar.jpg"/>
+          <p:cNvPicPr>
+            <a:picLocks noChangeAspect="1"/>
+          </p:cNvPicPr>
+          <p:nvPr/>
+        </p:nvPicPr>
+        <p:blipFill>
+          <a:blip r:embed="rId3"/>
+          <a:stretch>
+            <a:fillRect/>
+          </a:stretch>
+        </p:blipFill>
+        <p:spPr>
+          <a:xfrm>
+            <a:off x="9784080" y="2359152"/>
+            <a:ext cx="1312382" cy="402336"/>
+          </a:xfrm>
+          <a:prstGeom prst="rect">
+            <a:avLst/>
+          </a:prstGeom>
+        </p:spPr>
+      </p:pic>
+      <p:pic>
+        <p:nvPicPr>
+          <p:cNvPr id="11" name="Picture 10" descr="mrityunjay_chakraborty.jpg"/>
+          <p:cNvPicPr>
+            <a:picLocks noChangeAspect="1"/>
+          </p:cNvPicPr>
+          <p:nvPr/>
+        </p:nvPicPr>
+        <p:blipFill>
+          <a:blip r:embed="rId4"/>
+          <a:stretch>
+            <a:fillRect/>
+          </a:stretch>
+        </p:blipFill>
+        <p:spPr>
+          <a:xfrm>
+            <a:off x="9784080" y="3456432"/>
+            <a:ext cx="1471400" cy="402336"/>
+          </a:xfrm>
+          <a:prstGeom prst="rect">
+            <a:avLst/>
+          </a:prstGeom>
+        </p:spPr>
+      </p:pic>
+      <p:sp>
+        <p:nvSpPr>
+          <p:cNvPr id="12" name="TextBox 11"/>
+          <p:cNvSpPr txBox="1"/>
+          <p:nvPr/>
+        </p:nvSpPr>
+        <p:spPr>
+          <a:xfrm>
+            <a:off x="6400800" y="4023360"/>
+            <a:ext cx="5303520" cy="365760"/>
+          </a:xfrm>
+          <a:prstGeom prst="rect">
+            <a:avLst/>
+          </a:prstGeom>
+          <a:noFill/>
+        </p:spPr>
+        <p:txBody>
+          <a:bodyPr wrap="square" anchor="t" lIns="45720" rIns="45720">
+            <a:spAutoFit/>
+          </a:bodyPr>
+          <a:lstStyle/>
+          <a:p>
+            <a:pPr algn="l">
+              <a:spcAft>
+                <a:spcPts val="400"/>
+              </a:spcAft>
+            </a:pPr>
+            <a:r>
+              <a:rPr sz="1100" b="0">
+                <a:solidFill>
+                  <a:srgbClr val="555555"/>
+                </a:solidFill>
+                <a:latin typeface="Calibri"/>
+              </a:rPr>
+              <a:t>Signed 22 October 2026</a:t>
+            </a:r>
+          </a:p>
+        </p:txBody>
+      </p:sp>
     </p:spTree>
   </p:cSld>
   <p:clrMapOvr>
@@ -5117,7 +5228,7 @@
                 <a:latin typeface="Calibri"/>
               </a:rPr>
               <a:t>spot misconceptions,
-link a lecture</a:t>
+link a resource</a:t>
             </a:r>
           </a:p>
         </p:txBody>
@@ -5254,7 +5365,7 @@
                 </a:solidFill>
                 <a:latin typeface="Calibri"/>
               </a:rPr>
-              <a:t>to an earlier course
+              <a:t>to an earlier level
 if there is a gap</a:t>
             </a:r>
           </a:p>
@@ -5564,7 +5675,7 @@
                           </a:solidFill>
                           <a:latin typeface="Calibri"/>
                         </a:rPr>
-                        <a:t>topics with IDs and courses</a:t>
+                        <a:t>topics with IDs and levels</a:t>
                       </a:r>
                     </a:p>
                   </a:txBody>
@@ -5586,7 +5697,7 @@
                           </a:solidFill>
                           <a:latin typeface="Calibri"/>
                         </a:rPr>
-                        <a:t>“A is needed before B”, across courses</a:t>
+                        <a:t>“A is needed before B”, across levels</a:t>
                       </a:r>
                     </a:p>
                   </a:txBody>
@@ -5608,7 +5719,7 @@
                           </a:solidFill>
                           <a:latin typeface="Calibri"/>
                         </a:rPr>
-                        <a:t>transcripts, slides, PDFs</a:t>
+                        <a:t>PDFs, slides, transcripts</a:t>
                       </a:r>
                     </a:p>
                   </a:txBody>
@@ -5725,7 +5836,7 @@
                 </a:solidFill>
                 <a:latin typeface="Calibri"/>
               </a:rPr>
-              <a:t>Primary: IITM BS courses</a:t>
+              <a:t>Primary: NCERT content (any subject)</a:t>
             </a:r>
           </a:p>
           <a:p>
@@ -5741,7 +5852,7 @@
                 </a:solidFill>
                 <a:latin typeface="Calibri"/>
               </a:rPr>
-              <a:t>Maths &amp; Stats → MLF → MLT, e.g. “How does training happen in Linear Regression?”</a:t>
+              <a:t>public, complete data across classes and subjects</a:t>
             </a:r>
           </a:p>
         </p:txBody>
@@ -5826,7 +5937,7 @@
                 </a:solidFill>
                 <a:latin typeface="Calibri"/>
               </a:rPr>
-              <a:t>Second domain: NCERT Mathematics</a:t>
+              <a:t>Secondary: IITM BS course material</a:t>
             </a:r>
           </a:p>
           <a:p>
@@ -5842,7 +5953,7 @@
                 </a:solidFill>
                 <a:latin typeface="Calibri"/>
               </a:rPr>
-              <a:t>several classes that build on each other, to show the pipeline is reusable</a:t>
+              <a:t>Maths → MLF → MLT, e.g. “How does training happen in Linear Regression?”</a:t>
             </a:r>
           </a:p>
         </p:txBody>
@@ -5943,7 +6054,7 @@
                 </a:solidFill>
                 <a:latin typeface="Calibri"/>
               </a:rPr>
-              <a:t>Learning builds across courses</a:t>
+              <a:t>Learning builds across levels</a:t>
             </a:r>
           </a:p>
         </p:txBody>
@@ -5982,7 +6093,7 @@
                 </a:solidFill>
                 <a:latin typeface="Calibri"/>
               </a:rPr>
-              <a:t>If a learner is stuck, the tutor finds the gap in an earlier course</a:t>
+              <a:t>If a learner is stuck, the tutor finds the gap in an earlier level</a:t>
             </a:r>
           </a:p>
         </p:txBody>
@@ -6074,7 +6185,7 @@
         <p:spPr>
           <a:xfrm>
             <a:off x="548640" y="1600200"/>
-            <a:ext cx="2468880" cy="1280160"/>
+            <a:ext cx="3291840" cy="1280160"/>
           </a:xfrm>
           <a:prstGeom prst="roundRect">
             <a:avLst>
@@ -6120,7 +6231,7 @@
         <p:spPr>
           <a:xfrm>
             <a:off x="621792" y="1600200"/>
-            <a:ext cx="2322576" cy="1280160"/>
+            <a:ext cx="3145536" cy="1280160"/>
           </a:xfrm>
           <a:prstGeom prst="rect">
             <a:avLst/>
@@ -6139,13 +6250,13 @@
               </a:spcAft>
             </a:pPr>
             <a:r>
-              <a:rPr sz="1500" b="1">
+              <a:rPr sz="1600" b="1">
                 <a:solidFill>
                   <a:srgbClr val="1F1F1F"/>
                 </a:solidFill>
                 <a:latin typeface="Calibri"/>
               </a:rPr>
-              <a:t>Maths 1 · Stats 1</a:t>
+              <a:t>Level 1</a:t>
             </a:r>
           </a:p>
           <a:p>
@@ -6155,14 +6266,14 @@
               </a:spcAft>
             </a:pPr>
             <a:r>
-              <a:rPr sz="1400" b="0">
+              <a:rPr sz="1500" b="0">
                 <a:solidFill>
                   <a:srgbClr val="1F1F1F"/>
                 </a:solidFill>
                 <a:latin typeface="Calibri"/>
               </a:rPr>
-              <a:t>Functions, slope
-Mean, variance</a:t>
+              <a:t>Addition · Subtraction
+Multiplication</a:t>
             </a:r>
           </a:p>
         </p:txBody>
@@ -6175,8 +6286,8 @@
         </p:nvCxnSpPr>
         <p:spPr>
           <a:xfrm>
-            <a:off x="3017520" y="2240280"/>
-            <a:ext cx="365760" cy="0"/>
+            <a:off x="3840480" y="2240280"/>
+            <a:ext cx="548640" cy="0"/>
           </a:xfrm>
           <a:prstGeom prst="line">
             <a:avLst/>
@@ -6211,8 +6322,8 @@
         </p:nvSpPr>
         <p:spPr>
           <a:xfrm>
-            <a:off x="3383280" y="1600200"/>
-            <a:ext cx="2468880" cy="1280160"/>
+            <a:off x="4389120" y="1600200"/>
+            <a:ext cx="3291840" cy="1280160"/>
           </a:xfrm>
           <a:prstGeom prst="roundRect">
             <a:avLst>
@@ -6257,8 +6368,8 @@
         </p:nvSpPr>
         <p:spPr>
           <a:xfrm>
-            <a:off x="3456432" y="1600200"/>
-            <a:ext cx="2322576" cy="1280160"/>
+            <a:off x="4462272" y="1600200"/>
+            <a:ext cx="3145536" cy="1280160"/>
           </a:xfrm>
           <a:prstGeom prst="rect">
             <a:avLst/>
@@ -6277,13 +6388,13 @@
               </a:spcAft>
             </a:pPr>
             <a:r>
-              <a:rPr sz="1500" b="1">
+              <a:rPr sz="1600" b="1">
                 <a:solidFill>
                   <a:srgbClr val="1F1F1F"/>
                 </a:solidFill>
                 <a:latin typeface="Calibri"/>
               </a:rPr>
-              <a:t>Maths 2</a:t>
+              <a:t>Level 2</a:t>
             </a:r>
           </a:p>
           <a:p>
@@ -6293,14 +6404,14 @@
               </a:spcAft>
             </a:pPr>
             <a:r>
-              <a:rPr sz="1400" b="0">
+              <a:rPr sz="1500" b="0">
                 <a:solidFill>
                   <a:srgbClr val="1F1F1F"/>
                 </a:solidFill>
                 <a:latin typeface="Calibri"/>
               </a:rPr>
-              <a:t>Vectors, dot product
-Derivatives, chain rule</a:t>
+              <a:t>Division
+Fractions</a:t>
             </a:r>
           </a:p>
         </p:txBody>
@@ -6313,8 +6424,8 @@
         </p:nvCxnSpPr>
         <p:spPr>
           <a:xfrm>
-            <a:off x="5852160" y="2240280"/>
-            <a:ext cx="365760" cy="0"/>
+            <a:off x="7680960" y="2240280"/>
+            <a:ext cx="548640" cy="0"/>
           </a:xfrm>
           <a:prstGeom prst="line">
             <a:avLst/>
@@ -6349,8 +6460,8 @@
         </p:nvSpPr>
         <p:spPr>
           <a:xfrm>
-            <a:off x="6217920" y="1600200"/>
-            <a:ext cx="2468880" cy="1280160"/>
+            <a:off x="8229600" y="1600200"/>
+            <a:ext cx="3291840" cy="1280160"/>
           </a:xfrm>
           <a:prstGeom prst="roundRect">
             <a:avLst>
@@ -6358,7 +6469,7 @@
             </a:avLst>
           </a:prstGeom>
           <a:solidFill>
-            <a:srgbClr val="E6F2F3"/>
+            <a:srgbClr val="0F7C8C"/>
           </a:solidFill>
           <a:ln>
             <a:noFill/>
@@ -6395,8 +6506,8 @@
         </p:nvSpPr>
         <p:spPr>
           <a:xfrm>
-            <a:off x="6291072" y="1600200"/>
-            <a:ext cx="2322576" cy="1280160"/>
+            <a:off x="8302752" y="1600200"/>
+            <a:ext cx="3145536" cy="1280160"/>
           </a:xfrm>
           <a:prstGeom prst="rect">
             <a:avLst/>
@@ -6415,13 +6526,13 @@
               </a:spcAft>
             </a:pPr>
             <a:r>
-              <a:rPr sz="1500" b="1">
-                <a:solidFill>
-                  <a:srgbClr val="1F1F1F"/>
+              <a:rPr sz="1600" b="1">
+                <a:solidFill>
+                  <a:srgbClr val="FFFFFF"/>
                 </a:solidFill>
                 <a:latin typeface="Calibri"/>
               </a:rPr>
-              <a:t>MLF</a:t>
+              <a:t>Level 3</a:t>
             </a:r>
           </a:p>
           <a:p>
@@ -6431,159 +6542,21 @@
               </a:spcAft>
             </a:pPr>
             <a:r>
-              <a:rPr sz="1400" b="0">
-                <a:solidFill>
-                  <a:srgbClr val="1F1F1F"/>
+              <a:rPr sz="1500" b="0">
+                <a:solidFill>
+                  <a:srgbClr val="FFFFFF"/>
                 </a:solidFill>
                 <a:latin typeface="Calibri"/>
               </a:rPr>
-              <a:t>Loss functions
-Gradient descent</a:t>
-            </a:r>
-          </a:p>
-        </p:txBody>
-      </p:sp>
-      <p:cxnSp>
-        <p:nvCxnSpPr>
-          <p:cNvPr id="15" name="Connector 14"/>
-          <p:cNvCxnSpPr/>
-          <p:nvPr/>
-        </p:nvCxnSpPr>
-        <p:spPr>
-          <a:xfrm>
-            <a:off x="8686800" y="2240280"/>
-            <a:ext cx="365760" cy="0"/>
-          </a:xfrm>
-          <a:prstGeom prst="line">
-            <a:avLst/>
-          </a:prstGeom>
-          <a:ln w="19050">
-            <a:solidFill>
-              <a:srgbClr val="555555"/>
-            </a:solidFill>
-            <a:tailEnd type="triangle"/>
-          </a:ln>
-        </p:spPr>
-        <p:style>
-          <a:lnRef idx="2">
-            <a:schemeClr val="accent1"/>
-          </a:lnRef>
-          <a:fillRef idx="0">
-            <a:schemeClr val="accent1"/>
-          </a:fillRef>
-          <a:effectRef idx="1">
-            <a:schemeClr val="accent1"/>
-          </a:effectRef>
-          <a:fontRef idx="minor">
-            <a:schemeClr val="tx1"/>
-          </a:fontRef>
-        </p:style>
-      </p:cxnSp>
-      <p:sp>
-        <p:nvSpPr>
-          <p:cNvPr id="16" name="Rounded Rectangle 15"/>
-          <p:cNvSpPr/>
-          <p:nvPr/>
-        </p:nvSpPr>
-        <p:spPr>
-          <a:xfrm>
-            <a:off x="9052560" y="1600200"/>
-            <a:ext cx="2468880" cy="1280160"/>
-          </a:xfrm>
-          <a:prstGeom prst="roundRect">
-            <a:avLst>
-              <a:gd name="adj" fmla="val 8000"/>
-            </a:avLst>
-          </a:prstGeom>
-          <a:solidFill>
-            <a:srgbClr val="0F7C8C"/>
-          </a:solidFill>
-          <a:ln>
-            <a:noFill/>
-          </a:ln>
-          <a:effectLst/>
-        </p:spPr>
-        <p:style>
-          <a:lnRef idx="1">
-            <a:schemeClr val="accent1"/>
-          </a:lnRef>
-          <a:fillRef idx="3">
-            <a:schemeClr val="accent1"/>
-          </a:fillRef>
-          <a:effectRef idx="2">
-            <a:schemeClr val="accent1"/>
-          </a:effectRef>
-          <a:fontRef idx="minor">
-            <a:schemeClr val="lt1"/>
-          </a:fontRef>
-        </p:style>
-        <p:txBody>
-          <a:bodyPr rtlCol="0" anchor="ctr"/>
-          <a:lstStyle/>
-          <a:p>
-            <a:pPr algn="ctr"/>
-          </a:p>
-        </p:txBody>
-      </p:sp>
-      <p:sp>
-        <p:nvSpPr>
-          <p:cNvPr id="17" name="TextBox 16"/>
-          <p:cNvSpPr txBox="1"/>
-          <p:nvPr/>
-        </p:nvSpPr>
-        <p:spPr>
-          <a:xfrm>
-            <a:off x="9125712" y="1600200"/>
-            <a:ext cx="2322576" cy="1280160"/>
-          </a:xfrm>
-          <a:prstGeom prst="rect">
-            <a:avLst/>
-          </a:prstGeom>
-          <a:noFill/>
-        </p:spPr>
-        <p:txBody>
-          <a:bodyPr wrap="square" anchor="ctr" lIns="45720" rIns="45720">
-            <a:spAutoFit/>
-          </a:bodyPr>
-          <a:lstStyle/>
-          <a:p>
-            <a:pPr algn="ctr">
-              <a:spcAft>
-                <a:spcPts val="400"/>
-              </a:spcAft>
-            </a:pPr>
-            <a:r>
-              <a:rPr sz="1500" b="1">
-                <a:solidFill>
-                  <a:srgbClr val="FFFFFF"/>
-                </a:solidFill>
-                <a:latin typeface="Calibri"/>
-              </a:rPr>
-              <a:t>MLT</a:t>
-            </a:r>
-          </a:p>
-          <a:p>
-            <a:pPr algn="ctr">
-              <a:spcAft>
-                <a:spcPts val="400"/>
-              </a:spcAft>
-            </a:pPr>
-            <a:r>
-              <a:rPr sz="1400" b="0">
-                <a:solidFill>
-                  <a:srgbClr val="FFFFFF"/>
-                </a:solidFill>
-                <a:latin typeface="Calibri"/>
-              </a:rPr>
-              <a:t>Training linear
-regression</a:t>
-            </a:r>
-          </a:p>
-        </p:txBody>
-      </p:sp>
-      <p:sp>
-        <p:nvSpPr>
-          <p:cNvPr id="18" name="TextBox 17"/>
+              <a:t>Decimals
+Percentages</a:t>
+            </a:r>
+          </a:p>
+        </p:txBody>
+      </p:sp>
+      <p:sp>
+        <p:nvSpPr>
+          <p:cNvPr id="15" name="TextBox 14"/>
           <p:cNvSpPr txBox="1"/>
           <p:nvPr/>
         </p:nvSpPr>
@@ -6615,14 +6588,14 @@
                 </a:solidFill>
                 <a:latin typeface="Calibri"/>
               </a:rPr>
-              <a:t>Example: “How does training happen in Linear Regression?”</a:t>
+              <a:t>Example: stuck on “What is 20% of 50?”</a:t>
             </a:r>
           </a:p>
         </p:txBody>
       </p:sp>
       <p:graphicFrame>
         <p:nvGraphicFramePr>
-          <p:cNvPr id="19" name="Table 18"/>
+          <p:cNvPr id="16" name="Table 15"/>
           <p:cNvGraphicFramePr>
             <a:graphicFrameLocks noGrp="1"/>
           </p:cNvGraphicFramePr>
@@ -6723,7 +6696,7 @@
                           </a:solidFill>
                           <a:latin typeface="Calibri"/>
                         </a:rPr>
-                        <a:t>Supervised learning → prediction y = w·x → squared error → “what is dL/dw?”</a:t>
+                        <a:t>“What does 20% mean: 20 out of how many?”</a:t>
                       </a:r>
                     </a:p>
                   </a:txBody>
@@ -6769,7 +6742,7 @@
                           </a:solidFill>
                           <a:latin typeface="Calibri"/>
                         </a:rPr>
-                        <a:t>Gap found in derivatives (Maths 2) → checks slope of a line (Maths 1) if needed</a:t>
+                        <a:t>Gap found in fractions (Level 2) → checks division → multiplication (Level 1) if needed</a:t>
                       </a:r>
                     </a:p>
                   </a:txBody>
@@ -6815,7 +6788,7 @@
                           </a:solidFill>
                           <a:latin typeface="Calibri"/>
                         </a:rPr>
-                        <a:t>A few slope and derivative questions with hints and a link to the Maths 2 lecture</a:t>
+                        <a:t>A few division and fraction questions with hints and a link to the NCERT page</a:t>
                       </a:r>
                     </a:p>
                   </a:txBody>
@@ -6861,7 +6834,7 @@
                           </a:solidFill>
                           <a:latin typeface="Calibri"/>
                         </a:rPr>
-                        <a:t>derivative of w² → chain rule → gradient → gradient descent update (MLF, MLT)</a:t>
+                        <a:t>1/5 of 50 → 1/4 of 20 → back to 20% of 50 → harder: 15% of 60</a:t>
                       </a:r>
                     </a:p>
                   </a:txBody>
@@ -7663,7 +7636,7 @@
                 </a:solidFill>
                 <a:latin typeface="Calibri"/>
               </a:rPr>
-              <a:t>•  Backtracking across courses, then climbing back up to the learner’s question</a:t>
+              <a:t>•  Backtracking across levels, then climbing back up to the learner’s question</a:t>
             </a:r>
           </a:p>
           <a:p>
@@ -7679,7 +7652,7 @@
                 </a:solidFill>
                 <a:latin typeface="Calibri"/>
               </a:rPr>
-              <a:t>•  Feedback with the exact IITM lecture, slide or assignment to revisit; works for any course</a:t>
+              <a:t>•  Feedback with the exact page, video or notes to revisit; works for any course</a:t>
             </a:r>
           </a:p>
         </p:txBody>
@@ -8447,7 +8420,7 @@
                           </a:solidFill>
                           <a:latin typeface="Calibri"/>
                         </a:rPr>
-                        <a:t>Decides: probe, hint, backtrack a course, retest, move up</a:t>
+                        <a:t>Decides: probe, hint, backtrack a level, retest, move up</a:t>
                       </a:r>
                     </a:p>
                   </a:txBody>
@@ -8515,7 +8488,7 @@
                           </a:solidFill>
                           <a:latin typeface="Calibri"/>
                         </a:rPr>
-                        <a:t>Qwen3-4B + LoRA on tutoring dialogues + our IITM BS examples: writes probing questions</a:t>
+                        <a:t>Qwen3-4B + LoRA on tutoring dialogues + our NCERT and IITM examples: writes probing questions</a:t>
                       </a:r>
                     </a:p>
                   </a:txBody>
@@ -8583,7 +8556,7 @@
                           </a:solidFill>
                           <a:latin typeface="Calibri"/>
                         </a:rPr>
-                        <a:t>Spots common error patterns (e.g. a sign error in the gradient)</a:t>
+                        <a:t>Spots common error patterns (e.g. 50 ÷ 20 instead of 20/100 × 50)</a:t>
                       </a:r>
                     </a:p>
                   </a:txBody>
@@ -8651,7 +8624,7 @@
                           </a:solidFill>
                           <a:latin typeface="Calibri"/>
                         </a:rPr>
-                        <a:t>Finds the lecture, slide or assignment for a concept</a:t>
+                        <a:t>Finds the page, video or notes for a concept</a:t>
                       </a:r>
                     </a:p>
                   </a:txBody>
@@ -9072,7 +9045,7 @@
                           </a:solidFill>
                           <a:latin typeface="Calibri"/>
                         </a:rPr>
-                        <a:t>IITM BS transcripts</a:t>
+                        <a:t>NCERT textbooks</a:t>
                       </a:r>
                     </a:p>
                   </a:txBody>
@@ -9116,7 +9089,7 @@
                           </a:solidFill>
                           <a:latin typeface="Calibri"/>
                         </a:rPr>
-                        <a:t>gathered by us</a:t>
+                        <a:t>several classes and subjects</a:t>
                       </a:r>
                     </a:p>
                   </a:txBody>
@@ -9276,7 +9249,7 @@
                           </a:solidFill>
                           <a:latin typeface="Calibri"/>
                         </a:rPr>
-                        <a:t>Tutoring dialogues + our IITM examples</a:t>
+                        <a:t>Tutoring dialogues + our examples</a:t>
                       </a:r>
                     </a:p>
                   </a:txBody>
@@ -9344,7 +9317,7 @@
                           </a:solidFill>
                           <a:latin typeface="Calibri"/>
                         </a:rPr>
-                        <a:t>NCERT Maths</a:t>
+                        <a:t>IITM BS transcripts</a:t>
                       </a:r>
                     </a:p>
                   </a:txBody>
@@ -9366,7 +9339,7 @@
                           </a:solidFill>
                           <a:latin typeface="Calibri"/>
                         </a:rPr>
-                        <a:t>Course pack (second)</a:t>
+                        <a:t>Course pack (secondary)</a:t>
                       </a:r>
                     </a:p>
                   </a:txBody>
@@ -9388,7 +9361,7 @@
                           </a:solidFill>
                           <a:latin typeface="Calibri"/>
                         </a:rPr>
-                        <a:t>several classes</a:t>
+                        <a:t>gathered by us</a:t>
                       </a:r>
                     </a:p>
                   </a:txBody>
@@ -9437,7 +9410,7 @@
                 </a:solidFill>
                 <a:latin typeface="Calibri"/>
               </a:rPr>
-              <a:t>Why ASSISTments for DKT: real, time-ordered student answers (IITM has none public); the standard DKT benchmark, so our results can be checked; maths skills; free for research.</a:t>
+              <a:t>Why ASSISTments for DKT: real, time-ordered student answers (none public for NCERT/IITM); the standard DKT benchmark, so our results can be checked; maths skills; free for research.</a:t>
             </a:r>
           </a:p>
           <a:p>
@@ -9829,7 +9802,7 @@
                 </a:solidFill>
                 <a:latin typeface="Calibri"/>
               </a:rPr>
-              <a:t>IITM BS training example → Socratic model</a:t>
+              <a:t>NCERT training example → Socratic model</a:t>
             </a:r>
           </a:p>
         </p:txBody>
@@ -9930,7 +9903,7 @@
                 </a:solidFill>
                 <a:latin typeface="Calibri"/>
               </a:rPr>
-              <a:t>Concept: derivatives (Maths 2)</a:t>
+              <a:t>Concept: percentages (Level 3); prerequisite: fractions (Level 2)</a:t>
             </a:r>
           </a:p>
           <a:p>
@@ -9946,7 +9919,7 @@
                 </a:solidFill>
                 <a:latin typeface="Calibri"/>
               </a:rPr>
-              <a:t>Question: For L(w) = (6 − 2w)², what is dL/dw?</a:t>
+              <a:t>Question: What is 20% of 50?</a:t>
             </a:r>
           </a:p>
           <a:p>
@@ -9962,7 +9935,7 @@
                 </a:solidFill>
                 <a:latin typeface="Calibri"/>
               </a:rPr>
-              <a:t>Learner: “I don’t know”</a:t>
+              <a:t>Learner: “2.5”</a:t>
             </a:r>
           </a:p>
           <a:p>
@@ -9978,7 +9951,7 @@
                 </a:solidFill>
                 <a:latin typeface="Calibri"/>
               </a:rPr>
-              <a:t>Controller action: PROBE (a prerequisite); don’t reveal the answer</a:t>
+              <a:t>Controller action: PROBE the meaning of percent; don’t reveal the answer</a:t>
             </a:r>
           </a:p>
           <a:p>
@@ -9994,7 +9967,7 @@
                 </a:solidFill>
                 <a:latin typeface="Calibri"/>
               </a:rPr>
-              <a:t>Resource: Maths 2, Week 5, Lecture 2 (08:15)</a:t>
+              <a:t>Resource: NCERT Mathematics, chapter on percentages</a:t>
             </a:r>
           </a:p>
           <a:p>
@@ -10026,7 +9999,7 @@
                 </a:solidFill>
                 <a:latin typeface="Calibri"/>
               </a:rPr>
-              <a:t>“Let’s step back. For y = 3x + 1, how much does y change when x increases by 1?”</a:t>
+              <a:t>“Let’s check together. What does 20% mean: 20 out of how many?”</a:t>
             </a:r>
           </a:p>
           <a:p>
@@ -10555,7 +10528,7 @@
                           </a:solidFill>
                           <a:latin typeface="Calibri"/>
                         </a:rPr>
-                        <a:t>% gaps found in the right course</a:t>
+                        <a:t>% gaps found at the right level</a:t>
                       </a:r>
                     </a:p>
                   </a:txBody>
@@ -10867,7 +10840,7 @@
                 </a:solidFill>
                 <a:latin typeface="Calibri"/>
               </a:rPr>
-              <a:t>•  60–100 annotated IITM scenarios (careless slip, gap 1 course back, gap 2 courses back…) + any provided test samples</a:t>
+              <a:t>•  60–100 annotated NCERT scenarios (careless slip, gap 1 level down, gap 2 levels down…) + any provided test samples</a:t>
             </a:r>
           </a:p>
           <a:p>
@@ -10899,7 +10872,7 @@
                 </a:solidFill>
                 <a:latin typeface="Calibri"/>
               </a:rPr>
-              <a:t>•  Same tests on the IITM BS and NCERT course packs, with no code changes</a:t>
+              <a:t>•  Same tests on the NCERT and IITM BS course packs, with no code changes</a:t>
             </a:r>
           </a:p>
         </p:txBody>
@@ -11092,7 +11065,7 @@
         <p:spPr>
           <a:xfrm>
             <a:off x="548640" y="1143000"/>
-            <a:ext cx="6766560" cy="3931920"/>
+            <a:ext cx="6766560" cy="3566160"/>
           </a:xfrm>
           <a:prstGeom prst="roundRect">
             <a:avLst>
@@ -11140,7 +11113,7 @@
         <p:spPr>
           <a:xfrm>
             <a:off x="685800" y="1188720"/>
-            <a:ext cx="6583680" cy="4937760"/>
+            <a:ext cx="6583680" cy="3474720"/>
           </a:xfrm>
           <a:prstGeom prst="rect">
             <a:avLst/>
@@ -11165,7 +11138,7 @@
                 </a:solidFill>
                 <a:latin typeface="Calibri"/>
               </a:rPr>
-              <a:t>Learner: How does training happen in Linear Regression?</a:t>
+              <a:t>Learner: What is 20% of 50?  My answer: 2.5</a:t>
             </a:r>
           </a:p>
           <a:p>
@@ -11175,13 +11148,13 @@
               </a:spcAft>
             </a:pPr>
             <a:r>
-              <a:rPr sz="1100" b="0">
+              <a:rPr sz="1200" b="0">
                 <a:solidFill>
                   <a:srgbClr val="1F1F1F"/>
                 </a:solidFill>
                 <a:latin typeface="Calibri"/>
               </a:rPr>
-              <a:t>Tutor: In supervised learning, what do we give the model?   Learner: Inputs and outputs ✓</a:t>
+              <a:t>Tutor: What does 20% mean: 20 out of how many?   Learner: 100 ✓</a:t>
             </a:r>
           </a:p>
           <a:p>
@@ -11191,13 +11164,13 @@
               </a:spcAft>
             </a:pPr>
             <a:r>
-              <a:rPr sz="1100" b="0">
+              <a:rPr sz="1200" b="0">
                 <a:solidFill>
                   <a:srgbClr val="1F1F1F"/>
                 </a:solidFill>
                 <a:latin typeface="Calibri"/>
               </a:rPr>
-              <a:t>Tutor: y = w·x, w = [2,1], x = [3,4]. Prediction?   Learner: 10 ✓</a:t>
+              <a:t>Tutor: So 20% = 20/100. Simplest form?   Learner: I don’t know</a:t>
             </a:r>
           </a:p>
           <a:p>
@@ -11207,13 +11180,13 @@
               </a:spcAft>
             </a:pPr>
             <a:r>
-              <a:rPr sz="1100" b="0">
-                <a:solidFill>
-                  <a:srgbClr val="1F1F1F"/>
+              <a:rPr sz="1200" b="0">
+                <a:solidFill>
+                  <a:srgbClr val="0F7C8C"/>
                 </a:solidFill>
                 <a:latin typeface="Calibri"/>
               </a:rPr>
-              <a:t>Tutor: True y is 12. Squared error?   Learner: 4 ✓</a:t>
+              <a:t>[gap at Level 2 → checking division]</a:t>
             </a:r>
           </a:p>
           <a:p>
@@ -11223,13 +11196,13 @@
               </a:spcAft>
             </a:pPr>
             <a:r>
-              <a:rPr sz="1100" b="0">
+              <a:rPr sz="1200" b="0">
                 <a:solidFill>
                   <a:srgbClr val="1F1F1F"/>
                 </a:solidFill>
                 <a:latin typeface="Calibri"/>
               </a:rPr>
-              <a:t>Tutor: For L(w) = (6 − 2w)², what is dL/dw?   Learner: I don’t know</a:t>
+              <a:t>Tutor: What is 100 ÷ 20?   Learner: 5 ✓</a:t>
             </a:r>
           </a:p>
           <a:p>
@@ -11239,13 +11212,13 @@
               </a:spcAft>
             </a:pPr>
             <a:r>
-              <a:rPr sz="1100" b="0">
-                <a:solidFill>
-                  <a:srgbClr val="0F7C8C"/>
+              <a:rPr sz="1200" b="0">
+                <a:solidFill>
+                  <a:srgbClr val="1F1F1F"/>
                 </a:solidFill>
                 <a:latin typeface="Calibri"/>
               </a:rPr>
-              <a:t>[gap in Maths 2: derivatives → checking Maths 1: slope]</a:t>
+              <a:t>Tutor: So 20/100 = 1/5. What is 1/5 of 50?  Hint: 5 equal groups 📖</a:t>
             </a:r>
           </a:p>
           <a:p>
@@ -11255,13 +11228,13 @@
               </a:spcAft>
             </a:pPr>
             <a:r>
-              <a:rPr sz="1100" b="0">
+              <a:rPr sz="1200" b="0">
                 <a:solidFill>
                   <a:srgbClr val="1F1F1F"/>
                 </a:solidFill>
                 <a:latin typeface="Calibri"/>
               </a:rPr>
-              <a:t>Tutor: For y = 3x + 1, how much does y change when x goes up by 1?   Learner: 3 ✓</a:t>
+              <a:t>Learner: 10 ✓      Tutor: And 1/4 of 20?   Learner: 5 ✓</a:t>
             </a:r>
           </a:p>
           <a:p>
@@ -11271,13 +11244,13 @@
               </a:spcAft>
             </a:pPr>
             <a:r>
-              <a:rPr sz="1100" b="0">
-                <a:solidFill>
-                  <a:srgbClr val="1F1F1F"/>
+              <a:rPr sz="1200" b="0">
+                <a:solidFill>
+                  <a:srgbClr val="0F7C8C"/>
                 </a:solidFill>
                 <a:latin typeface="Calibri"/>
               </a:rPr>
-              <a:t>Tutor: Derivative of w²?  📺 Maths 2, Week 5, Lecture 2 (08:15)   Learner: 2w ✓</a:t>
+              <a:t>[back to Level 3]</a:t>
             </a:r>
           </a:p>
           <a:p>
@@ -11287,13 +11260,13 @@
               </a:spcAft>
             </a:pPr>
             <a:r>
-              <a:rPr sz="1100" b="0">
-                <a:solidFill>
-                  <a:srgbClr val="0F7C8C"/>
+              <a:rPr sz="1200" b="1">
+                <a:solidFill>
+                  <a:srgbClr val="1F1F1F"/>
                 </a:solidFill>
                 <a:latin typeface="Calibri"/>
               </a:rPr>
-              <a:t>[back to Maths 2]</a:t>
+              <a:t>Tutor: Try again: 20% of 50?   Learner: 10 ✓</a:t>
             </a:r>
           </a:p>
           <a:p>
@@ -11303,13 +11276,13 @@
               </a:spcAft>
             </a:pPr>
             <a:r>
-              <a:rPr sz="1100" b="0">
+              <a:rPr sz="1200" b="0">
                 <a:solidFill>
                   <a:srgbClr val="1F1F1F"/>
                 </a:solidFill>
                 <a:latin typeface="Calibri"/>
               </a:rPr>
-              <a:t>Tutor: Chain rule on (6 − 2w)²?   Learner: −4(6 − 2w) ✓</a:t>
+              <a:t>Tutor: Earlier you divided 50 by 20; a percentage means “out of 100”.</a:t>
             </a:r>
           </a:p>
           <a:p>
@@ -11319,45 +11292,13 @@
               </a:spcAft>
             </a:pPr>
             <a:r>
-              <a:rPr sz="1100" b="0">
-                <a:solidFill>
-                  <a:srgbClr val="0F7C8C"/>
+              <a:rPr sz="1200" b="0">
+                <a:solidFill>
+                  <a:srgbClr val="1F1F1F"/>
                 </a:solidFill>
                 <a:latin typeface="Calibri"/>
               </a:rPr>
-              <a:t>[back to MLF / MLT]</a:t>
-            </a:r>
-          </a:p>
-          <a:p>
-            <a:pPr algn="l">
-              <a:spcAft>
-                <a:spcPts val="400"/>
-              </a:spcAft>
-            </a:pPr>
-            <a:r>
-              <a:rPr sz="1100" b="0">
-                <a:solidFill>
-                  <a:srgbClr val="1F1F1F"/>
-                </a:solidFill>
-                <a:latin typeface="Calibri"/>
-              </a:rPr>
-              <a:t>Tutor: At w = 1 the gradient is −16. Should w go up or down?   Learner: Up ✓</a:t>
-            </a:r>
-          </a:p>
-          <a:p>
-            <a:pPr algn="l">
-              <a:spcAft>
-                <a:spcPts val="400"/>
-              </a:spcAft>
-            </a:pPr>
-            <a:r>
-              <a:rPr sz="1100" b="1">
-                <a:solidFill>
-                  <a:srgbClr val="1F1F1F"/>
-                </a:solidFill>
-                <a:latin typeface="Calibri"/>
-              </a:rPr>
-              <a:t>Tutor: Exactly: w ← w − η × gradient. That’s how linear regression is trained!</a:t>
+              <a:t>         Next: 15% of 60?</a:t>
             </a:r>
           </a:p>
         </p:txBody>
@@ -11420,8 +11361,8 @@
                 <a:tableStyleId>{5C22544A-7EE6-4342-B048-85BDC9FD1C3A}</a:tableStyleId>
               </a:tblPr>
               <a:tblGrid>
-                <a:gridCol w="1737360"/>
-                <a:gridCol w="731520"/>
+                <a:gridCol w="1645920"/>
+                <a:gridCol w="822960"/>
                 <a:gridCol w="1554480"/>
               </a:tblGrid>
               <a:tr h="384048">
@@ -11437,7 +11378,7 @@
                           </a:solidFill>
                           <a:latin typeface="Calibri"/>
                         </a:rPr>
-                        <a:t>Course: concept</a:t>
+                        <a:t>Concept (level)</a:t>
                       </a:r>
                     </a:p>
                   </a:txBody>
@@ -11505,7 +11446,7 @@
                           </a:solidFill>
                           <a:latin typeface="Calibri"/>
                         </a:rPr>
-                        <a:t>Maths 1: slope</a:t>
+                        <a:t>Multiplication (1)</a:t>
                       </a:r>
                     </a:p>
                   </a:txBody>
@@ -11527,7 +11468,7 @@
                           </a:solidFill>
                           <a:latin typeface="Calibri"/>
                         </a:rPr>
-                        <a:t>2/2</a:t>
+                        <a:t>3/3</a:t>
                       </a:r>
                     </a:p>
                   </a:txBody>
@@ -11573,7 +11514,7 @@
                           </a:solidFill>
                           <a:latin typeface="Calibri"/>
                         </a:rPr>
-                        <a:t>Maths 2: derivatives</a:t>
+                        <a:t>Division (2)</a:t>
                       </a:r>
                     </a:p>
                   </a:txBody>
@@ -11595,7 +11536,7 @@
                           </a:solidFill>
                           <a:latin typeface="Calibri"/>
                         </a:rPr>
-                        <a:t>1/2</a:t>
+                        <a:t>2/2</a:t>
                       </a:r>
                     </a:p>
                   </a:txBody>
@@ -11617,7 +11558,7 @@
                           </a:solidFill>
                           <a:latin typeface="Calibri"/>
                         </a:rPr>
-                        <a:t>0.64</a:t>
+                        <a:t>0.84</a:t>
                       </a:r>
                     </a:p>
                   </a:txBody>
@@ -11641,7 +11582,7 @@
                           </a:solidFill>
                           <a:latin typeface="Calibri"/>
                         </a:rPr>
-                        <a:t>MLF: gradient descent</a:t>
+                        <a:t>Fractions (2)</a:t>
                       </a:r>
                     </a:p>
                   </a:txBody>
@@ -11663,7 +11604,7 @@
                           </a:solidFill>
                           <a:latin typeface="Calibri"/>
                         </a:rPr>
-                        <a:t>1/1</a:t>
+                        <a:t>1/2</a:t>
                       </a:r>
                     </a:p>
                   </a:txBody>
@@ -11685,7 +11626,7 @@
                           </a:solidFill>
                           <a:latin typeface="Calibri"/>
                         </a:rPr>
-                        <a:t>0.70</a:t>
+                        <a:t>0.66</a:t>
                       </a:r>
                     </a:p>
                   </a:txBody>
@@ -11709,7 +11650,7 @@
                           </a:solidFill>
                           <a:latin typeface="Calibri"/>
                         </a:rPr>
-                        <a:t>MLT: linear regression</a:t>
+                        <a:t>Percentages (3)</a:t>
                       </a:r>
                     </a:p>
                   </a:txBody>
@@ -11753,7 +11694,7 @@
                           </a:solidFill>
                           <a:latin typeface="Calibri"/>
                         </a:rPr>
-                        <a:t>0.60 · practise</a:t>
+                        <a:t>0.58 · practise</a:t>
                       </a:r>
                     </a:p>
                   </a:txBody>
@@ -11816,7 +11757,7 @@
         <p:spPr>
           <a:xfrm>
             <a:off x="7680960" y="4160520"/>
-            <a:ext cx="4023360" cy="2011680"/>
+            <a:ext cx="4023360" cy="1828800"/>
           </a:xfrm>
           <a:prstGeom prst="rect">
             <a:avLst/>
@@ -11841,7 +11782,7 @@
                 </a:solidFill>
                 <a:latin typeface="Calibri"/>
               </a:rPr>
-              <a:t>API + prompt: explains MSE and gradient descent all at once. Learner never checked; the derivative gap stays hidden.</a:t>
+              <a:t>API + prompt: “20/100 × 50 = 10.” Answer revealed; gap not found.</a:t>
             </a:r>
           </a:p>
           <a:p>
@@ -11857,7 +11798,7 @@
                 </a:solidFill>
                 <a:latin typeface="Calibri"/>
               </a:rPr>
-              <a:t>Ours: finds the derivative gap, revisits Maths 1 and 2, returns to MLT; learner works out the update rule.</a:t>
+              <a:t>Ours: finds the fraction gap, practises Level 2, returns to Level 3; learner finds 10.</a:t>
             </a:r>
           </a:p>
         </p:txBody>

</xml_diff>

<commit_message>
include hariom pandey signature
</commit_message>
<xml_diff>
--- a/docs/milestone-1/Milestone1_Presentation.pptx
+++ b/docs/milestone-1/Milestone1_Presentation.pptx
@@ -4576,7 +4576,7 @@
       </p:pic>
       <p:pic>
         <p:nvPicPr>
-          <p:cNvPr id="11" name="Picture 10" descr="mrityunjay_chakraborty.jpg"/>
+          <p:cNvPr id="11" name="Picture 10" descr="hariom_pandey.jpeg"/>
           <p:cNvPicPr>
             <a:picLocks noChangeAspect="1"/>
           </p:cNvPicPr>
@@ -4590,17 +4590,41 @@
         </p:blipFill>
         <p:spPr>
           <a:xfrm>
-            <a:off x="9784080" y="3456432"/>
-            <a:ext cx="1471400" cy="402336"/>
+            <a:off x="9784080" y="2907791"/>
+            <a:ext cx="956140" cy="402336"/>
           </a:xfrm>
           <a:prstGeom prst="rect">
             <a:avLst/>
           </a:prstGeom>
         </p:spPr>
       </p:pic>
-      <p:sp>
-        <p:nvSpPr>
-          <p:cNvPr id="12" name="TextBox 11"/>
+      <p:pic>
+        <p:nvPicPr>
+          <p:cNvPr id="12" name="Picture 11" descr="mrityunjay_chakraborty.jpg"/>
+          <p:cNvPicPr>
+            <a:picLocks noChangeAspect="1"/>
+          </p:cNvPicPr>
+          <p:nvPr/>
+        </p:nvPicPr>
+        <p:blipFill>
+          <a:blip r:embed="rId5"/>
+          <a:stretch>
+            <a:fillRect/>
+          </a:stretch>
+        </p:blipFill>
+        <p:spPr>
+          <a:xfrm>
+            <a:off x="9784080" y="3456432"/>
+            <a:ext cx="1471400" cy="402336"/>
+          </a:xfrm>
+          <a:prstGeom prst="rect">
+            <a:avLst/>
+          </a:prstGeom>
+        </p:spPr>
+      </p:pic>
+      <p:sp>
+        <p:nvSpPr>
+          <p:cNvPr id="13" name="TextBox 12"/>
           <p:cNvSpPr txBox="1"/>
           <p:nvPr/>
         </p:nvSpPr>

</xml_diff>